<commit_message>
Update team members and fix all documentation
</commit_message>
<xml_diff>
--- a/AI_Health_Assistant_Ethiopia_Final.pptx
+++ b/AI_Health_Assistant_Ethiopia_Final.pptx
@@ -5,24 +5,24 @@
     <p:sldMasterId id="2147483648" r:id="rId1"/>
   </p:sldMasterIdLst>
   <p:sldIdLst>
-    <p:sldId id="256" r:id="rId7"/>
-    <p:sldId id="257" r:id="rId8"/>
-    <p:sldId id="258" r:id="rId9"/>
-    <p:sldId id="259" r:id="rId10"/>
-    <p:sldId id="260" r:id="rId11"/>
-    <p:sldId id="261" r:id="rId12"/>
-    <p:sldId id="262" r:id="rId13"/>
-    <p:sldId id="263" r:id="rId14"/>
-    <p:sldId id="264" r:id="rId15"/>
-    <p:sldId id="265" r:id="rId16"/>
-    <p:sldId id="266" r:id="rId17"/>
-    <p:sldId id="267" r:id="rId18"/>
-    <p:sldId id="268" r:id="rId19"/>
-    <p:sldId id="269" r:id="rId20"/>
-    <p:sldId id="270" r:id="rId21"/>
-    <p:sldId id="271" r:id="rId22"/>
+    <p:sldId id="256" r:id="rId2"/>
+    <p:sldId id="257" r:id="rId3"/>
+    <p:sldId id="258" r:id="rId4"/>
+    <p:sldId id="259" r:id="rId5"/>
+    <p:sldId id="260" r:id="rId6"/>
+    <p:sldId id="261" r:id="rId7"/>
+    <p:sldId id="262" r:id="rId8"/>
+    <p:sldId id="263" r:id="rId9"/>
+    <p:sldId id="264" r:id="rId10"/>
+    <p:sldId id="265" r:id="rId11"/>
+    <p:sldId id="266" r:id="rId12"/>
+    <p:sldId id="267" r:id="rId13"/>
+    <p:sldId id="268" r:id="rId14"/>
+    <p:sldId id="269" r:id="rId15"/>
+    <p:sldId id="270" r:id="rId16"/>
+    <p:sldId id="271" r:id="rId17"/>
   </p:sldIdLst>
-  <p:sldSz cx="12188952" cy="6858000" type="screen4x3"/>
+  <p:sldSz cx="12188825" cy="6858000"/>
   <p:notesSz cx="6858000" cy="9144000"/>
   <p:defaultTextStyle>
     <a:defPPr>
@@ -119,6 +119,22 @@
       </a:defRPr>
     </a:lvl9pPr>
   </p:defaultTextStyle>
+  <p:extLst>
+    <p:ext uri="{EFAFB233-063F-42B5-8137-9DF3F51BA10A}">
+      <p15:sldGuideLst xmlns:p15="http://schemas.microsoft.com/office/powerpoint/2012/main">
+        <p15:guide id="1" orient="horz" pos="2160">
+          <p15:clr>
+            <a:srgbClr val="A4A3A4"/>
+          </p15:clr>
+        </p15:guide>
+        <p15:guide id="2" pos="2880">
+          <p15:clr>
+            <a:srgbClr val="A4A3A4"/>
+          </p15:clr>
+        </p15:guide>
+      </p15:sldGuideLst>
+    </p:ext>
+  </p:extLst>
 </p:presentation>
 </file>
 
@@ -160,10 +176,9 @@
           <a:lstStyle/>
           <a:p>
             <a:r>
-              <a:rPr lang="en-US" smtClean="0"/>
+              <a:rPr lang="en-US"/>
               <a:t>Click to edit Master title style</a:t>
             </a:r>
-            <a:endParaRPr lang="en-US"/>
           </a:p>
         </p:txBody>
       </p:sp>
@@ -279,10 +294,9 @@
           </a:lstStyle>
           <a:p>
             <a:r>
-              <a:rPr lang="en-US" smtClean="0"/>
+              <a:rPr lang="en-US"/>
               <a:t>Click to edit Master subtitle style</a:t>
             </a:r>
-            <a:endParaRPr lang="en-US"/>
           </a:p>
         </p:txBody>
       </p:sp>
@@ -303,7 +317,7 @@
           <a:p>
             <a:fld id="{5BCAD085-E8A6-8845-BD4E-CB4CCA059FC4}" type="datetimeFigureOut">
               <a:rPr lang="en-US" smtClean="0"/>
-              <a:t>1/27/13</a:t>
+              <a:t>5/16/2026</a:t>
             </a:fld>
             <a:endParaRPr lang="en-US"/>
           </a:p>
@@ -397,10 +411,9 @@
           <a:lstStyle/>
           <a:p>
             <a:r>
-              <a:rPr lang="en-US" smtClean="0"/>
+              <a:rPr lang="en-US"/>
               <a:t>Click to edit Master title style</a:t>
             </a:r>
-            <a:endParaRPr lang="en-US"/>
           </a:p>
         </p:txBody>
       </p:sp>
@@ -421,38 +434,37 @@
           <a:p>
             <a:pPr lvl="0"/>
             <a:r>
-              <a:rPr lang="en-US" smtClean="0"/>
+              <a:rPr lang="en-US"/>
               <a:t>Click to edit Master text styles</a:t>
             </a:r>
           </a:p>
           <a:p>
             <a:pPr lvl="1"/>
             <a:r>
-              <a:rPr lang="en-US" smtClean="0"/>
+              <a:rPr lang="en-US"/>
               <a:t>Second level</a:t>
             </a:r>
           </a:p>
           <a:p>
             <a:pPr lvl="2"/>
             <a:r>
-              <a:rPr lang="en-US" smtClean="0"/>
+              <a:rPr lang="en-US"/>
               <a:t>Third level</a:t>
             </a:r>
           </a:p>
           <a:p>
             <a:pPr lvl="3"/>
             <a:r>
-              <a:rPr lang="en-US" smtClean="0"/>
+              <a:rPr lang="en-US"/>
               <a:t>Fourth level</a:t>
             </a:r>
           </a:p>
           <a:p>
             <a:pPr lvl="4"/>
             <a:r>
-              <a:rPr lang="en-US" smtClean="0"/>
+              <a:rPr lang="en-US"/>
               <a:t>Fifth level</a:t>
             </a:r>
-            <a:endParaRPr lang="en-US"/>
           </a:p>
         </p:txBody>
       </p:sp>
@@ -473,7 +485,7 @@
           <a:p>
             <a:fld id="{5BCAD085-E8A6-8845-BD4E-CB4CCA059FC4}" type="datetimeFigureOut">
               <a:rPr lang="en-US" smtClean="0"/>
-              <a:t>1/27/13</a:t>
+              <a:t>5/16/2026</a:t>
             </a:fld>
             <a:endParaRPr lang="en-US"/>
           </a:p>
@@ -572,10 +584,9 @@
           <a:lstStyle/>
           <a:p>
             <a:r>
-              <a:rPr lang="en-US" smtClean="0"/>
+              <a:rPr lang="en-US"/>
               <a:t>Click to edit Master title style</a:t>
             </a:r>
-            <a:endParaRPr lang="en-US"/>
           </a:p>
         </p:txBody>
       </p:sp>
@@ -601,38 +612,37 @@
           <a:p>
             <a:pPr lvl="0"/>
             <a:r>
-              <a:rPr lang="en-US" smtClean="0"/>
+              <a:rPr lang="en-US"/>
               <a:t>Click to edit Master text styles</a:t>
             </a:r>
           </a:p>
           <a:p>
             <a:pPr lvl="1"/>
             <a:r>
-              <a:rPr lang="en-US" smtClean="0"/>
+              <a:rPr lang="en-US"/>
               <a:t>Second level</a:t>
             </a:r>
           </a:p>
           <a:p>
             <a:pPr lvl="2"/>
             <a:r>
-              <a:rPr lang="en-US" smtClean="0"/>
+              <a:rPr lang="en-US"/>
               <a:t>Third level</a:t>
             </a:r>
           </a:p>
           <a:p>
             <a:pPr lvl="3"/>
             <a:r>
-              <a:rPr lang="en-US" smtClean="0"/>
+              <a:rPr lang="en-US"/>
               <a:t>Fourth level</a:t>
             </a:r>
           </a:p>
           <a:p>
             <a:pPr lvl="4"/>
             <a:r>
-              <a:rPr lang="en-US" smtClean="0"/>
+              <a:rPr lang="en-US"/>
               <a:t>Fifth level</a:t>
             </a:r>
-            <a:endParaRPr lang="en-US"/>
           </a:p>
         </p:txBody>
       </p:sp>
@@ -653,7 +663,7 @@
           <a:p>
             <a:fld id="{5BCAD085-E8A6-8845-BD4E-CB4CCA059FC4}" type="datetimeFigureOut">
               <a:rPr lang="en-US" smtClean="0"/>
-              <a:t>1/27/13</a:t>
+              <a:t>5/16/2026</a:t>
             </a:fld>
             <a:endParaRPr lang="en-US"/>
           </a:p>
@@ -747,10 +757,9 @@
           <a:lstStyle/>
           <a:p>
             <a:r>
-              <a:rPr lang="en-US" smtClean="0"/>
+              <a:rPr lang="en-US"/>
               <a:t>Click to edit Master title style</a:t>
             </a:r>
-            <a:endParaRPr lang="en-US"/>
           </a:p>
         </p:txBody>
       </p:sp>
@@ -771,38 +780,37 @@
           <a:p>
             <a:pPr lvl="0"/>
             <a:r>
-              <a:rPr lang="en-US" smtClean="0"/>
+              <a:rPr lang="en-US"/>
               <a:t>Click to edit Master text styles</a:t>
             </a:r>
           </a:p>
           <a:p>
             <a:pPr lvl="1"/>
             <a:r>
-              <a:rPr lang="en-US" smtClean="0"/>
+              <a:rPr lang="en-US"/>
               <a:t>Second level</a:t>
             </a:r>
           </a:p>
           <a:p>
             <a:pPr lvl="2"/>
             <a:r>
-              <a:rPr lang="en-US" smtClean="0"/>
+              <a:rPr lang="en-US"/>
               <a:t>Third level</a:t>
             </a:r>
           </a:p>
           <a:p>
             <a:pPr lvl="3"/>
             <a:r>
-              <a:rPr lang="en-US" smtClean="0"/>
+              <a:rPr lang="en-US"/>
               <a:t>Fourth level</a:t>
             </a:r>
           </a:p>
           <a:p>
             <a:pPr lvl="4"/>
             <a:r>
-              <a:rPr lang="en-US" smtClean="0"/>
+              <a:rPr lang="en-US"/>
               <a:t>Fifth level</a:t>
             </a:r>
-            <a:endParaRPr lang="en-US"/>
           </a:p>
         </p:txBody>
       </p:sp>
@@ -823,7 +831,7 @@
           <a:p>
             <a:fld id="{5BCAD085-E8A6-8845-BD4E-CB4CCA059FC4}" type="datetimeFigureOut">
               <a:rPr lang="en-US" smtClean="0"/>
-              <a:t>1/27/13</a:t>
+              <a:t>5/16/2026</a:t>
             </a:fld>
             <a:endParaRPr lang="en-US"/>
           </a:p>
@@ -926,10 +934,9 @@
           </a:lstStyle>
           <a:p>
             <a:r>
-              <a:rPr lang="en-US" smtClean="0"/>
+              <a:rPr lang="en-US"/>
               <a:t>Click to edit Master title style</a:t>
             </a:r>
-            <a:endParaRPr lang="en-US"/>
           </a:p>
         </p:txBody>
       </p:sp>
@@ -1046,7 +1053,7 @@
           <a:p>
             <a:pPr lvl="0"/>
             <a:r>
-              <a:rPr lang="en-US" smtClean="0"/>
+              <a:rPr lang="en-US"/>
               <a:t>Click to edit Master text styles</a:t>
             </a:r>
           </a:p>
@@ -1069,7 +1076,7 @@
           <a:p>
             <a:fld id="{5BCAD085-E8A6-8845-BD4E-CB4CCA059FC4}" type="datetimeFigureOut">
               <a:rPr lang="en-US" smtClean="0"/>
-              <a:t>1/27/13</a:t>
+              <a:t>5/16/2026</a:t>
             </a:fld>
             <a:endParaRPr lang="en-US"/>
           </a:p>
@@ -1163,10 +1170,9 @@
           <a:lstStyle/>
           <a:p>
             <a:r>
-              <a:rPr lang="en-US" smtClean="0"/>
+              <a:rPr lang="en-US"/>
               <a:t>Click to edit Master title style</a:t>
             </a:r>
-            <a:endParaRPr lang="en-US"/>
           </a:p>
         </p:txBody>
       </p:sp>
@@ -1220,38 +1226,37 @@
           <a:p>
             <a:pPr lvl="0"/>
             <a:r>
-              <a:rPr lang="en-US" smtClean="0"/>
+              <a:rPr lang="en-US"/>
               <a:t>Click to edit Master text styles</a:t>
             </a:r>
           </a:p>
           <a:p>
             <a:pPr lvl="1"/>
             <a:r>
-              <a:rPr lang="en-US" smtClean="0"/>
+              <a:rPr lang="en-US"/>
               <a:t>Second level</a:t>
             </a:r>
           </a:p>
           <a:p>
             <a:pPr lvl="2"/>
             <a:r>
-              <a:rPr lang="en-US" smtClean="0"/>
+              <a:rPr lang="en-US"/>
               <a:t>Third level</a:t>
             </a:r>
           </a:p>
           <a:p>
             <a:pPr lvl="3"/>
             <a:r>
-              <a:rPr lang="en-US" smtClean="0"/>
+              <a:rPr lang="en-US"/>
               <a:t>Fourth level</a:t>
             </a:r>
           </a:p>
           <a:p>
             <a:pPr lvl="4"/>
             <a:r>
-              <a:rPr lang="en-US" smtClean="0"/>
+              <a:rPr lang="en-US"/>
               <a:t>Fifth level</a:t>
             </a:r>
-            <a:endParaRPr lang="en-US"/>
           </a:p>
         </p:txBody>
       </p:sp>
@@ -1305,38 +1310,37 @@
           <a:p>
             <a:pPr lvl="0"/>
             <a:r>
-              <a:rPr lang="en-US" smtClean="0"/>
+              <a:rPr lang="en-US"/>
               <a:t>Click to edit Master text styles</a:t>
             </a:r>
           </a:p>
           <a:p>
             <a:pPr lvl="1"/>
             <a:r>
-              <a:rPr lang="en-US" smtClean="0"/>
+              <a:rPr lang="en-US"/>
               <a:t>Second level</a:t>
             </a:r>
           </a:p>
           <a:p>
             <a:pPr lvl="2"/>
             <a:r>
-              <a:rPr lang="en-US" smtClean="0"/>
+              <a:rPr lang="en-US"/>
               <a:t>Third level</a:t>
             </a:r>
           </a:p>
           <a:p>
             <a:pPr lvl="3"/>
             <a:r>
-              <a:rPr lang="en-US" smtClean="0"/>
+              <a:rPr lang="en-US"/>
               <a:t>Fourth level</a:t>
             </a:r>
           </a:p>
           <a:p>
             <a:pPr lvl="4"/>
             <a:r>
-              <a:rPr lang="en-US" smtClean="0"/>
+              <a:rPr lang="en-US"/>
               <a:t>Fifth level</a:t>
             </a:r>
-            <a:endParaRPr lang="en-US"/>
           </a:p>
         </p:txBody>
       </p:sp>
@@ -1357,7 +1361,7 @@
           <a:p>
             <a:fld id="{5BCAD085-E8A6-8845-BD4E-CB4CCA059FC4}" type="datetimeFigureOut">
               <a:rPr lang="en-US" smtClean="0"/>
-              <a:t>1/27/13</a:t>
+              <a:t>5/16/2026</a:t>
             </a:fld>
             <a:endParaRPr lang="en-US"/>
           </a:p>
@@ -1455,10 +1459,9 @@
           </a:lstStyle>
           <a:p>
             <a:r>
-              <a:rPr lang="en-US" smtClean="0"/>
+              <a:rPr lang="en-US"/>
               <a:t>Click to edit Master title style</a:t>
             </a:r>
-            <a:endParaRPr lang="en-US"/>
           </a:p>
         </p:txBody>
       </p:sp>
@@ -1521,7 +1524,7 @@
           <a:p>
             <a:pPr lvl="0"/>
             <a:r>
-              <a:rPr lang="en-US" smtClean="0"/>
+              <a:rPr lang="en-US"/>
               <a:t>Click to edit Master text styles</a:t>
             </a:r>
           </a:p>
@@ -1577,38 +1580,37 @@
           <a:p>
             <a:pPr lvl="0"/>
             <a:r>
-              <a:rPr lang="en-US" smtClean="0"/>
+              <a:rPr lang="en-US"/>
               <a:t>Click to edit Master text styles</a:t>
             </a:r>
           </a:p>
           <a:p>
             <a:pPr lvl="1"/>
             <a:r>
-              <a:rPr lang="en-US" smtClean="0"/>
+              <a:rPr lang="en-US"/>
               <a:t>Second level</a:t>
             </a:r>
           </a:p>
           <a:p>
             <a:pPr lvl="2"/>
             <a:r>
-              <a:rPr lang="en-US" smtClean="0"/>
+              <a:rPr lang="en-US"/>
               <a:t>Third level</a:t>
             </a:r>
           </a:p>
           <a:p>
             <a:pPr lvl="3"/>
             <a:r>
-              <a:rPr lang="en-US" smtClean="0"/>
+              <a:rPr lang="en-US"/>
               <a:t>Fourth level</a:t>
             </a:r>
           </a:p>
           <a:p>
             <a:pPr lvl="4"/>
             <a:r>
-              <a:rPr lang="en-US" smtClean="0"/>
+              <a:rPr lang="en-US"/>
               <a:t>Fifth level</a:t>
             </a:r>
-            <a:endParaRPr lang="en-US"/>
           </a:p>
         </p:txBody>
       </p:sp>
@@ -1671,7 +1673,7 @@
           <a:p>
             <a:pPr lvl="0"/>
             <a:r>
-              <a:rPr lang="en-US" smtClean="0"/>
+              <a:rPr lang="en-US"/>
               <a:t>Click to edit Master text styles</a:t>
             </a:r>
           </a:p>
@@ -1727,38 +1729,37 @@
           <a:p>
             <a:pPr lvl="0"/>
             <a:r>
-              <a:rPr lang="en-US" smtClean="0"/>
+              <a:rPr lang="en-US"/>
               <a:t>Click to edit Master text styles</a:t>
             </a:r>
           </a:p>
           <a:p>
             <a:pPr lvl="1"/>
             <a:r>
-              <a:rPr lang="en-US" smtClean="0"/>
+              <a:rPr lang="en-US"/>
               <a:t>Second level</a:t>
             </a:r>
           </a:p>
           <a:p>
             <a:pPr lvl="2"/>
             <a:r>
-              <a:rPr lang="en-US" smtClean="0"/>
+              <a:rPr lang="en-US"/>
               <a:t>Third level</a:t>
             </a:r>
           </a:p>
           <a:p>
             <a:pPr lvl="3"/>
             <a:r>
-              <a:rPr lang="en-US" smtClean="0"/>
+              <a:rPr lang="en-US"/>
               <a:t>Fourth level</a:t>
             </a:r>
           </a:p>
           <a:p>
             <a:pPr lvl="4"/>
             <a:r>
-              <a:rPr lang="en-US" smtClean="0"/>
+              <a:rPr lang="en-US"/>
               <a:t>Fifth level</a:t>
             </a:r>
-            <a:endParaRPr lang="en-US"/>
           </a:p>
         </p:txBody>
       </p:sp>
@@ -1779,7 +1780,7 @@
           <a:p>
             <a:fld id="{5BCAD085-E8A6-8845-BD4E-CB4CCA059FC4}" type="datetimeFigureOut">
               <a:rPr lang="en-US" smtClean="0"/>
-              <a:t>1/27/13</a:t>
+              <a:t>5/16/2026</a:t>
             </a:fld>
             <a:endParaRPr lang="en-US"/>
           </a:p>
@@ -1873,10 +1874,9 @@
           <a:lstStyle/>
           <a:p>
             <a:r>
-              <a:rPr lang="en-US" smtClean="0"/>
+              <a:rPr lang="en-US"/>
               <a:t>Click to edit Master title style</a:t>
             </a:r>
-            <a:endParaRPr lang="en-US"/>
           </a:p>
         </p:txBody>
       </p:sp>
@@ -1897,7 +1897,7 @@
           <a:p>
             <a:fld id="{5BCAD085-E8A6-8845-BD4E-CB4CCA059FC4}" type="datetimeFigureOut">
               <a:rPr lang="en-US" smtClean="0"/>
-              <a:t>1/27/13</a:t>
+              <a:t>5/16/2026</a:t>
             </a:fld>
             <a:endParaRPr lang="en-US"/>
           </a:p>
@@ -1992,7 +1992,7 @@
           <a:p>
             <a:fld id="{5BCAD085-E8A6-8845-BD4E-CB4CCA059FC4}" type="datetimeFigureOut">
               <a:rPr lang="en-US" smtClean="0"/>
-              <a:t>1/27/13</a:t>
+              <a:t>5/16/2026</a:t>
             </a:fld>
             <a:endParaRPr lang="en-US"/>
           </a:p>
@@ -2095,10 +2095,9 @@
           </a:lstStyle>
           <a:p>
             <a:r>
-              <a:rPr lang="en-US" smtClean="0"/>
+              <a:rPr lang="en-US"/>
               <a:t>Click to edit Master title style</a:t>
             </a:r>
-            <a:endParaRPr lang="en-US"/>
           </a:p>
         </p:txBody>
       </p:sp>
@@ -2152,38 +2151,37 @@
           <a:p>
             <a:pPr lvl="0"/>
             <a:r>
-              <a:rPr lang="en-US" smtClean="0"/>
+              <a:rPr lang="en-US"/>
               <a:t>Click to edit Master text styles</a:t>
             </a:r>
           </a:p>
           <a:p>
             <a:pPr lvl="1"/>
             <a:r>
-              <a:rPr lang="en-US" smtClean="0"/>
+              <a:rPr lang="en-US"/>
               <a:t>Second level</a:t>
             </a:r>
           </a:p>
           <a:p>
             <a:pPr lvl="2"/>
             <a:r>
-              <a:rPr lang="en-US" smtClean="0"/>
+              <a:rPr lang="en-US"/>
               <a:t>Third level</a:t>
             </a:r>
           </a:p>
           <a:p>
             <a:pPr lvl="3"/>
             <a:r>
-              <a:rPr lang="en-US" smtClean="0"/>
+              <a:rPr lang="en-US"/>
               <a:t>Fourth level</a:t>
             </a:r>
           </a:p>
           <a:p>
             <a:pPr lvl="4"/>
             <a:r>
-              <a:rPr lang="en-US" smtClean="0"/>
+              <a:rPr lang="en-US"/>
               <a:t>Fifth level</a:t>
             </a:r>
-            <a:endParaRPr lang="en-US"/>
           </a:p>
         </p:txBody>
       </p:sp>
@@ -2246,7 +2244,7 @@
           <a:p>
             <a:pPr lvl="0"/>
             <a:r>
-              <a:rPr lang="en-US" smtClean="0"/>
+              <a:rPr lang="en-US"/>
               <a:t>Click to edit Master text styles</a:t>
             </a:r>
           </a:p>
@@ -2269,7 +2267,7 @@
           <a:p>
             <a:fld id="{5BCAD085-E8A6-8845-BD4E-CB4CCA059FC4}" type="datetimeFigureOut">
               <a:rPr lang="en-US" smtClean="0"/>
-              <a:t>1/27/13</a:t>
+              <a:t>5/16/2026</a:t>
             </a:fld>
             <a:endParaRPr lang="en-US"/>
           </a:p>
@@ -2372,10 +2370,9 @@
           </a:lstStyle>
           <a:p>
             <a:r>
-              <a:rPr lang="en-US" smtClean="0"/>
+              <a:rPr lang="en-US"/>
               <a:t>Click to edit Master title style</a:t>
             </a:r>
-            <a:endParaRPr lang="en-US"/>
           </a:p>
         </p:txBody>
       </p:sp>
@@ -2499,7 +2496,7 @@
           <a:p>
             <a:pPr lvl="0"/>
             <a:r>
-              <a:rPr lang="en-US" smtClean="0"/>
+              <a:rPr lang="en-US"/>
               <a:t>Click to edit Master text styles</a:t>
             </a:r>
           </a:p>
@@ -2522,7 +2519,7 @@
           <a:p>
             <a:fld id="{5BCAD085-E8A6-8845-BD4E-CB4CCA059FC4}" type="datetimeFigureOut">
               <a:rPr lang="en-US" smtClean="0"/>
-              <a:t>1/27/13</a:t>
+              <a:t>5/16/2026</a:t>
             </a:fld>
             <a:endParaRPr lang="en-US"/>
           </a:p>
@@ -2631,10 +2628,9 @@
           <a:lstStyle/>
           <a:p>
             <a:r>
-              <a:rPr lang="en-US" smtClean="0"/>
+              <a:rPr lang="en-US"/>
               <a:t>Click to edit Master title style</a:t>
             </a:r>
-            <a:endParaRPr lang="en-US"/>
           </a:p>
         </p:txBody>
       </p:sp>
@@ -2665,38 +2661,37 @@
           <a:p>
             <a:pPr lvl="0"/>
             <a:r>
-              <a:rPr lang="en-US" smtClean="0"/>
+              <a:rPr lang="en-US"/>
               <a:t>Click to edit Master text styles</a:t>
             </a:r>
           </a:p>
           <a:p>
             <a:pPr lvl="1"/>
             <a:r>
-              <a:rPr lang="en-US" smtClean="0"/>
+              <a:rPr lang="en-US"/>
               <a:t>Second level</a:t>
             </a:r>
           </a:p>
           <a:p>
             <a:pPr lvl="2"/>
             <a:r>
-              <a:rPr lang="en-US" smtClean="0"/>
+              <a:rPr lang="en-US"/>
               <a:t>Third level</a:t>
             </a:r>
           </a:p>
           <a:p>
             <a:pPr lvl="3"/>
             <a:r>
-              <a:rPr lang="en-US" smtClean="0"/>
+              <a:rPr lang="en-US"/>
               <a:t>Fourth level</a:t>
             </a:r>
           </a:p>
           <a:p>
             <a:pPr lvl="4"/>
             <a:r>
-              <a:rPr lang="en-US" smtClean="0"/>
+              <a:rPr lang="en-US"/>
               <a:t>Fifth level</a:t>
             </a:r>
-            <a:endParaRPr lang="en-US"/>
           </a:p>
         </p:txBody>
       </p:sp>
@@ -2735,7 +2730,7 @@
           <a:p>
             <a:fld id="{5BCAD085-E8A6-8845-BD4E-CB4CCA059FC4}" type="datetimeFigureOut">
               <a:rPr lang="en-US" smtClean="0"/>
-              <a:t>1/27/13</a:t>
+              <a:t>5/16/2026</a:t>
             </a:fld>
             <a:endParaRPr lang="en-US"/>
           </a:p>
@@ -3094,7 +3089,7 @@
 </file>
 
 <file path=ppt/slides/slide1.xml><?xml version="1.0" encoding="utf-8"?>
-<p:sld xmlns:a="http://schemas.openxmlformats.org/drawingml/2006/main" xmlns:p="http://schemas.openxmlformats.org/presentationml/2006/main" xmlns:r="http://schemas.openxmlformats.org/officeDocument/2006/relationships">
+<p:sld xmlns:a="http://schemas.openxmlformats.org/drawingml/2006/main" xmlns:r="http://schemas.openxmlformats.org/officeDocument/2006/relationships" xmlns:p="http://schemas.openxmlformats.org/presentationml/2006/main">
   <p:cSld>
     <p:bg>
       <p:bgPr>
@@ -3110,7 +3105,14 @@
         <p:cNvGrpSpPr/>
         <p:nvPr/>
       </p:nvGrpSpPr>
-      <p:grpSpPr/>
+      <p:grpSpPr>
+        <a:xfrm>
+          <a:off x="0" y="0"/>
+          <a:ext cx="0" cy="0"/>
+          <a:chOff x="0" y="0"/>
+          <a:chExt cx="0" cy="0"/>
+        </a:xfrm>
+      </p:grpSpPr>
       <p:sp>
         <p:nvSpPr>
           <p:cNvPr id="2" name="Rectangle 1"/>
@@ -3151,6 +3153,7 @@
           <a:lstStyle/>
           <a:p>
             <a:pPr algn="ctr"/>
+            <a:endParaRPr/>
           </a:p>
         </p:txBody>
       </p:sp>
@@ -3194,6 +3197,7 @@
           <a:lstStyle/>
           <a:p>
             <a:pPr algn="ctr"/>
+            <a:endParaRPr/>
           </a:p>
         </p:txBody>
       </p:sp>
@@ -3305,6 +3309,7 @@
           <a:lstStyle/>
           <a:p>
             <a:pPr algn="ctr"/>
+            <a:endParaRPr/>
           </a:p>
         </p:txBody>
       </p:sp>
@@ -3453,7 +3458,7 @@
 </file>
 
 <file path=ppt/slides/slide10.xml><?xml version="1.0" encoding="utf-8"?>
-<p:sld xmlns:a="http://schemas.openxmlformats.org/drawingml/2006/main" xmlns:p="http://schemas.openxmlformats.org/presentationml/2006/main" xmlns:r="http://schemas.openxmlformats.org/officeDocument/2006/relationships">
+<p:sld xmlns:a="http://schemas.openxmlformats.org/drawingml/2006/main" xmlns:r="http://schemas.openxmlformats.org/officeDocument/2006/relationships" xmlns:p="http://schemas.openxmlformats.org/presentationml/2006/main">
   <p:cSld>
     <p:bg>
       <p:bgPr>
@@ -3469,7 +3474,14 @@
         <p:cNvGrpSpPr/>
         <p:nvPr/>
       </p:nvGrpSpPr>
-      <p:grpSpPr/>
+      <p:grpSpPr>
+        <a:xfrm>
+          <a:off x="0" y="0"/>
+          <a:ext cx="0" cy="0"/>
+          <a:chOff x="0" y="0"/>
+          <a:chExt cx="0" cy="0"/>
+        </a:xfrm>
+      </p:grpSpPr>
       <p:sp>
         <p:nvSpPr>
           <p:cNvPr id="2" name="Rectangle 1"/>
@@ -3510,6 +3522,7 @@
           <a:lstStyle/>
           <a:p>
             <a:pPr algn="ctr"/>
+            <a:endParaRPr/>
           </a:p>
         </p:txBody>
       </p:sp>
@@ -3587,6 +3600,7 @@
           <a:lstStyle/>
           <a:p>
             <a:pPr algn="ctr"/>
+            <a:endParaRPr/>
           </a:p>
         </p:txBody>
       </p:sp>
@@ -3664,6 +3678,7 @@
           <a:lstStyle/>
           <a:p>
             <a:pPr algn="ctr"/>
+            <a:endParaRPr/>
           </a:p>
         </p:txBody>
       </p:sp>
@@ -3741,6 +3756,7 @@
           <a:lstStyle/>
           <a:p>
             <a:pPr algn="ctr"/>
+            <a:endParaRPr/>
           </a:p>
         </p:txBody>
       </p:sp>
@@ -3818,6 +3834,7 @@
           <a:lstStyle/>
           <a:p>
             <a:pPr algn="ctr"/>
+            <a:endParaRPr/>
           </a:p>
         </p:txBody>
       </p:sp>
@@ -3929,6 +3946,7 @@
           <a:lstStyle/>
           <a:p>
             <a:pPr algn="ctr"/>
+            <a:endParaRPr/>
           </a:p>
         </p:txBody>
       </p:sp>
@@ -4006,6 +4024,7 @@
           <a:lstStyle/>
           <a:p>
             <a:pPr algn="ctr"/>
+            <a:endParaRPr/>
           </a:p>
         </p:txBody>
       </p:sp>
@@ -4117,6 +4136,7 @@
           <a:lstStyle/>
           <a:p>
             <a:pPr algn="ctr"/>
+            <a:endParaRPr/>
           </a:p>
         </p:txBody>
       </p:sp>
@@ -4194,6 +4214,7 @@
           <a:lstStyle/>
           <a:p>
             <a:pPr algn="ctr"/>
+            <a:endParaRPr/>
           </a:p>
         </p:txBody>
       </p:sp>
@@ -4271,6 +4292,7 @@
           <a:lstStyle/>
           <a:p>
             <a:pPr algn="ctr"/>
+            <a:endParaRPr/>
           </a:p>
         </p:txBody>
       </p:sp>
@@ -4317,7 +4339,7 @@
 </file>
 
 <file path=ppt/slides/slide11.xml><?xml version="1.0" encoding="utf-8"?>
-<p:sld xmlns:a="http://schemas.openxmlformats.org/drawingml/2006/main" xmlns:p="http://schemas.openxmlformats.org/presentationml/2006/main" xmlns:r="http://schemas.openxmlformats.org/officeDocument/2006/relationships">
+<p:sld xmlns:a="http://schemas.openxmlformats.org/drawingml/2006/main" xmlns:r="http://schemas.openxmlformats.org/officeDocument/2006/relationships" xmlns:p="http://schemas.openxmlformats.org/presentationml/2006/main">
   <p:cSld>
     <p:bg>
       <p:bgPr>
@@ -4333,7 +4355,14 @@
         <p:cNvGrpSpPr/>
         <p:nvPr/>
       </p:nvGrpSpPr>
-      <p:grpSpPr/>
+      <p:grpSpPr>
+        <a:xfrm>
+          <a:off x="0" y="0"/>
+          <a:ext cx="0" cy="0"/>
+          <a:chOff x="0" y="0"/>
+          <a:chExt cx="0" cy="0"/>
+        </a:xfrm>
+      </p:grpSpPr>
       <p:sp>
         <p:nvSpPr>
           <p:cNvPr id="2" name="Rectangle 1"/>
@@ -4374,6 +4403,7 @@
           <a:lstStyle/>
           <a:p>
             <a:pPr algn="ctr"/>
+            <a:endParaRPr/>
           </a:p>
         </p:txBody>
       </p:sp>
@@ -4451,6 +4481,7 @@
           <a:lstStyle/>
           <a:p>
             <a:pPr algn="ctr"/>
+            <a:endParaRPr/>
           </a:p>
         </p:txBody>
       </p:sp>
@@ -4528,6 +4559,7 @@
           <a:lstStyle/>
           <a:p>
             <a:pPr algn="ctr"/>
+            <a:endParaRPr/>
           </a:p>
         </p:txBody>
       </p:sp>
@@ -4605,6 +4637,7 @@
           <a:lstStyle/>
           <a:p>
             <a:pPr algn="ctr"/>
+            <a:endParaRPr/>
           </a:p>
         </p:txBody>
       </p:sp>
@@ -4682,6 +4715,7 @@
           <a:lstStyle/>
           <a:p>
             <a:pPr algn="ctr"/>
+            <a:endParaRPr/>
           </a:p>
         </p:txBody>
       </p:sp>
@@ -4759,6 +4793,7 @@
           <a:lstStyle/>
           <a:p>
             <a:pPr algn="ctr"/>
+            <a:endParaRPr/>
           </a:p>
         </p:txBody>
       </p:sp>
@@ -4836,6 +4871,7 @@
           <a:lstStyle/>
           <a:p>
             <a:pPr algn="ctr"/>
+            <a:endParaRPr/>
           </a:p>
         </p:txBody>
       </p:sp>
@@ -4913,6 +4949,7 @@
           <a:lstStyle/>
           <a:p>
             <a:pPr algn="ctr"/>
+            <a:endParaRPr/>
           </a:p>
         </p:txBody>
       </p:sp>
@@ -4990,6 +5027,7 @@
           <a:lstStyle/>
           <a:p>
             <a:pPr algn="ctr"/>
+            <a:endParaRPr/>
           </a:p>
         </p:txBody>
       </p:sp>
@@ -5101,6 +5139,7 @@
           <a:lstStyle/>
           <a:p>
             <a:pPr algn="ctr"/>
+            <a:endParaRPr/>
           </a:p>
         </p:txBody>
       </p:sp>
@@ -5178,6 +5217,7 @@
           <a:lstStyle/>
           <a:p>
             <a:pPr algn="ctr"/>
+            <a:endParaRPr/>
           </a:p>
         </p:txBody>
       </p:sp>
@@ -5224,7 +5264,7 @@
 </file>
 
 <file path=ppt/slides/slide12.xml><?xml version="1.0" encoding="utf-8"?>
-<p:sld xmlns:a="http://schemas.openxmlformats.org/drawingml/2006/main" xmlns:p="http://schemas.openxmlformats.org/presentationml/2006/main" xmlns:r="http://schemas.openxmlformats.org/officeDocument/2006/relationships">
+<p:sld xmlns:a="http://schemas.openxmlformats.org/drawingml/2006/main" xmlns:r="http://schemas.openxmlformats.org/officeDocument/2006/relationships" xmlns:p="http://schemas.openxmlformats.org/presentationml/2006/main">
   <p:cSld>
     <p:bg>
       <p:bgPr>
@@ -5240,7 +5280,14 @@
         <p:cNvGrpSpPr/>
         <p:nvPr/>
       </p:nvGrpSpPr>
-      <p:grpSpPr/>
+      <p:grpSpPr>
+        <a:xfrm>
+          <a:off x="0" y="0"/>
+          <a:ext cx="0" cy="0"/>
+          <a:chOff x="0" y="0"/>
+          <a:chExt cx="0" cy="0"/>
+        </a:xfrm>
+      </p:grpSpPr>
       <p:sp>
         <p:nvSpPr>
           <p:cNvPr id="2" name="Rectangle 1"/>
@@ -5281,6 +5328,7 @@
           <a:lstStyle/>
           <a:p>
             <a:pPr algn="ctr"/>
+            <a:endParaRPr/>
           </a:p>
         </p:txBody>
       </p:sp>
@@ -5358,6 +5406,7 @@
           <a:lstStyle/>
           <a:p>
             <a:pPr algn="ctr"/>
+            <a:endParaRPr/>
           </a:p>
         </p:txBody>
       </p:sp>
@@ -5435,6 +5484,7 @@
           <a:lstStyle/>
           <a:p>
             <a:pPr algn="ctr"/>
+            <a:endParaRPr/>
           </a:p>
         </p:txBody>
       </p:sp>
@@ -5546,6 +5596,7 @@
           <a:lstStyle/>
           <a:p>
             <a:pPr algn="ctr"/>
+            <a:endParaRPr/>
           </a:p>
         </p:txBody>
       </p:sp>
@@ -5623,6 +5674,7 @@
           <a:lstStyle/>
           <a:p>
             <a:pPr algn="ctr"/>
+            <a:endParaRPr/>
           </a:p>
         </p:txBody>
       </p:sp>
@@ -5734,6 +5786,7 @@
           <a:lstStyle/>
           <a:p>
             <a:pPr algn="ctr"/>
+            <a:endParaRPr/>
           </a:p>
         </p:txBody>
       </p:sp>
@@ -5811,6 +5864,7 @@
           <a:lstStyle/>
           <a:p>
             <a:pPr algn="ctr"/>
+            <a:endParaRPr/>
           </a:p>
         </p:txBody>
       </p:sp>
@@ -5888,6 +5942,7 @@
           <a:lstStyle/>
           <a:p>
             <a:pPr algn="ctr"/>
+            <a:endParaRPr/>
           </a:p>
         </p:txBody>
       </p:sp>
@@ -5965,6 +6020,7 @@
           <a:lstStyle/>
           <a:p>
             <a:pPr algn="ctr"/>
+            <a:endParaRPr/>
           </a:p>
         </p:txBody>
       </p:sp>
@@ -6042,6 +6098,7 @@
           <a:lstStyle/>
           <a:p>
             <a:pPr algn="ctr"/>
+            <a:endParaRPr/>
           </a:p>
         </p:txBody>
       </p:sp>
@@ -6088,7 +6145,7 @@
 </file>
 
 <file path=ppt/slides/slide13.xml><?xml version="1.0" encoding="utf-8"?>
-<p:sld xmlns:a="http://schemas.openxmlformats.org/drawingml/2006/main" xmlns:p="http://schemas.openxmlformats.org/presentationml/2006/main" xmlns:r="http://schemas.openxmlformats.org/officeDocument/2006/relationships">
+<p:sld xmlns:a="http://schemas.openxmlformats.org/drawingml/2006/main" xmlns:r="http://schemas.openxmlformats.org/officeDocument/2006/relationships" xmlns:p="http://schemas.openxmlformats.org/presentationml/2006/main">
   <p:cSld>
     <p:bg>
       <p:bgPr>
@@ -6104,7 +6161,14 @@
         <p:cNvGrpSpPr/>
         <p:nvPr/>
       </p:nvGrpSpPr>
-      <p:grpSpPr/>
+      <p:grpSpPr>
+        <a:xfrm>
+          <a:off x="0" y="0"/>
+          <a:ext cx="0" cy="0"/>
+          <a:chOff x="0" y="0"/>
+          <a:chExt cx="0" cy="0"/>
+        </a:xfrm>
+      </p:grpSpPr>
       <p:sp>
         <p:nvSpPr>
           <p:cNvPr id="2" name="Rectangle 1"/>
@@ -6145,6 +6209,7 @@
           <a:lstStyle/>
           <a:p>
             <a:pPr algn="ctr"/>
+            <a:endParaRPr/>
           </a:p>
         </p:txBody>
       </p:sp>
@@ -6222,6 +6287,7 @@
           <a:lstStyle/>
           <a:p>
             <a:pPr algn="ctr"/>
+            <a:endParaRPr/>
           </a:p>
         </p:txBody>
       </p:sp>
@@ -6265,6 +6331,7 @@
           <a:lstStyle/>
           <a:p>
             <a:pPr algn="ctr"/>
+            <a:endParaRPr/>
           </a:p>
         </p:txBody>
       </p:sp>
@@ -6342,6 +6409,7 @@
           <a:lstStyle/>
           <a:p>
             <a:pPr algn="ctr"/>
+            <a:endParaRPr/>
           </a:p>
         </p:txBody>
       </p:sp>
@@ -6419,6 +6487,7 @@
           <a:lstStyle/>
           <a:p>
             <a:pPr algn="ctr"/>
+            <a:endParaRPr/>
           </a:p>
         </p:txBody>
       </p:sp>
@@ -6496,6 +6565,7 @@
           <a:lstStyle/>
           <a:p>
             <a:pPr algn="ctr"/>
+            <a:endParaRPr/>
           </a:p>
         </p:txBody>
       </p:sp>
@@ -6573,6 +6643,7 @@
           <a:lstStyle/>
           <a:p>
             <a:pPr algn="ctr"/>
+            <a:endParaRPr/>
           </a:p>
         </p:txBody>
       </p:sp>
@@ -6650,6 +6721,7 @@
           <a:lstStyle/>
           <a:p>
             <a:pPr algn="ctr"/>
+            <a:endParaRPr/>
           </a:p>
         </p:txBody>
       </p:sp>
@@ -6727,6 +6799,7 @@
           <a:lstStyle/>
           <a:p>
             <a:pPr algn="ctr"/>
+            <a:endParaRPr/>
           </a:p>
         </p:txBody>
       </p:sp>
@@ -6804,6 +6877,7 @@
           <a:lstStyle/>
           <a:p>
             <a:pPr algn="ctr"/>
+            <a:endParaRPr/>
           </a:p>
         </p:txBody>
       </p:sp>
@@ -6881,6 +6955,7 @@
           <a:lstStyle/>
           <a:p>
             <a:pPr algn="ctr"/>
+            <a:endParaRPr/>
           </a:p>
         </p:txBody>
       </p:sp>
@@ -6927,7 +7002,7 @@
 </file>
 
 <file path=ppt/slides/slide14.xml><?xml version="1.0" encoding="utf-8"?>
-<p:sld xmlns:a="http://schemas.openxmlformats.org/drawingml/2006/main" xmlns:p="http://schemas.openxmlformats.org/presentationml/2006/main" xmlns:r="http://schemas.openxmlformats.org/officeDocument/2006/relationships">
+<p:sld xmlns:a="http://schemas.openxmlformats.org/drawingml/2006/main" xmlns:r="http://schemas.openxmlformats.org/officeDocument/2006/relationships" xmlns:p="http://schemas.openxmlformats.org/presentationml/2006/main">
   <p:cSld>
     <p:bg>
       <p:bgPr>
@@ -6943,7 +7018,14 @@
         <p:cNvGrpSpPr/>
         <p:nvPr/>
       </p:nvGrpSpPr>
-      <p:grpSpPr/>
+      <p:grpSpPr>
+        <a:xfrm>
+          <a:off x="0" y="0"/>
+          <a:ext cx="0" cy="0"/>
+          <a:chOff x="0" y="0"/>
+          <a:chExt cx="0" cy="0"/>
+        </a:xfrm>
+      </p:grpSpPr>
       <p:sp>
         <p:nvSpPr>
           <p:cNvPr id="2" name="Rectangle 1"/>
@@ -6984,6 +7066,7 @@
           <a:lstStyle/>
           <a:p>
             <a:pPr algn="ctr"/>
+            <a:endParaRPr/>
           </a:p>
         </p:txBody>
       </p:sp>
@@ -7061,6 +7144,7 @@
           <a:lstStyle/>
           <a:p>
             <a:pPr algn="ctr"/>
+            <a:endParaRPr/>
           </a:p>
         </p:txBody>
       </p:sp>
@@ -7104,6 +7188,7 @@
           <a:lstStyle/>
           <a:p>
             <a:pPr algn="ctr"/>
+            <a:endParaRPr/>
           </a:p>
         </p:txBody>
       </p:sp>
@@ -7181,6 +7266,7 @@
           <a:lstStyle/>
           <a:p>
             <a:pPr algn="ctr"/>
+            <a:endParaRPr/>
           </a:p>
         </p:txBody>
       </p:sp>
@@ -7258,6 +7344,7 @@
           <a:lstStyle/>
           <a:p>
             <a:pPr algn="ctr"/>
+            <a:endParaRPr/>
           </a:p>
         </p:txBody>
       </p:sp>
@@ -7335,6 +7422,7 @@
           <a:lstStyle/>
           <a:p>
             <a:pPr algn="ctr"/>
+            <a:endParaRPr/>
           </a:p>
         </p:txBody>
       </p:sp>
@@ -7412,6 +7500,7 @@
           <a:lstStyle/>
           <a:p>
             <a:pPr algn="ctr"/>
+            <a:endParaRPr/>
           </a:p>
         </p:txBody>
       </p:sp>
@@ -7489,6 +7578,7 @@
           <a:lstStyle/>
           <a:p>
             <a:pPr algn="ctr"/>
+            <a:endParaRPr/>
           </a:p>
         </p:txBody>
       </p:sp>
@@ -7566,6 +7656,7 @@
           <a:lstStyle/>
           <a:p>
             <a:pPr algn="ctr"/>
+            <a:endParaRPr/>
           </a:p>
         </p:txBody>
       </p:sp>
@@ -7643,6 +7734,7 @@
           <a:lstStyle/>
           <a:p>
             <a:pPr algn="ctr"/>
+            <a:endParaRPr/>
           </a:p>
         </p:txBody>
       </p:sp>
@@ -7689,7 +7781,7 @@
 </file>
 
 <file path=ppt/slides/slide15.xml><?xml version="1.0" encoding="utf-8"?>
-<p:sld xmlns:a="http://schemas.openxmlformats.org/drawingml/2006/main" xmlns:p="http://schemas.openxmlformats.org/presentationml/2006/main" xmlns:r="http://schemas.openxmlformats.org/officeDocument/2006/relationships">
+<p:sld xmlns:a="http://schemas.openxmlformats.org/drawingml/2006/main" xmlns:r="http://schemas.openxmlformats.org/officeDocument/2006/relationships" xmlns:p="http://schemas.openxmlformats.org/presentationml/2006/main">
   <p:cSld>
     <p:bg>
       <p:bgPr>
@@ -7705,7 +7797,14 @@
         <p:cNvGrpSpPr/>
         <p:nvPr/>
       </p:nvGrpSpPr>
-      <p:grpSpPr/>
+      <p:grpSpPr>
+        <a:xfrm>
+          <a:off x="0" y="0"/>
+          <a:ext cx="0" cy="0"/>
+          <a:chOff x="0" y="0"/>
+          <a:chExt cx="0" cy="0"/>
+        </a:xfrm>
+      </p:grpSpPr>
       <p:sp>
         <p:nvSpPr>
           <p:cNvPr id="2" name="Rectangle 1"/>
@@ -7746,6 +7845,7 @@
           <a:lstStyle/>
           <a:p>
             <a:pPr algn="ctr"/>
+            <a:endParaRPr/>
           </a:p>
         </p:txBody>
       </p:sp>
@@ -7823,6 +7923,7 @@
           <a:lstStyle/>
           <a:p>
             <a:pPr algn="ctr"/>
+            <a:endParaRPr/>
           </a:p>
         </p:txBody>
       </p:sp>
@@ -7900,6 +8001,7 @@
           <a:lstStyle/>
           <a:p>
             <a:pPr algn="ctr"/>
+            <a:endParaRPr/>
           </a:p>
         </p:txBody>
       </p:sp>
@@ -7977,6 +8079,7 @@
           <a:lstStyle/>
           <a:p>
             <a:pPr algn="ctr"/>
+            <a:endParaRPr/>
           </a:p>
         </p:txBody>
       </p:sp>
@@ -8054,6 +8157,7 @@
           <a:lstStyle/>
           <a:p>
             <a:pPr algn="ctr"/>
+            <a:endParaRPr/>
           </a:p>
         </p:txBody>
       </p:sp>
@@ -8131,6 +8235,7 @@
           <a:lstStyle/>
           <a:p>
             <a:pPr algn="ctr"/>
+            <a:endParaRPr/>
           </a:p>
         </p:txBody>
       </p:sp>
@@ -8208,6 +8313,7 @@
           <a:lstStyle/>
           <a:p>
             <a:pPr algn="ctr"/>
+            <a:endParaRPr/>
           </a:p>
         </p:txBody>
       </p:sp>
@@ -8319,6 +8425,7 @@
           <a:lstStyle/>
           <a:p>
             <a:pPr algn="ctr"/>
+            <a:endParaRPr/>
           </a:p>
         </p:txBody>
       </p:sp>
@@ -8396,6 +8503,7 @@
           <a:lstStyle/>
           <a:p>
             <a:pPr algn="ctr"/>
+            <a:endParaRPr/>
           </a:p>
         </p:txBody>
       </p:sp>
@@ -8473,6 +8581,7 @@
           <a:lstStyle/>
           <a:p>
             <a:pPr algn="ctr"/>
+            <a:endParaRPr/>
           </a:p>
         </p:txBody>
       </p:sp>
@@ -8550,6 +8659,7 @@
           <a:lstStyle/>
           <a:p>
             <a:pPr algn="ctr"/>
+            <a:endParaRPr/>
           </a:p>
         </p:txBody>
       </p:sp>
@@ -8596,7 +8706,7 @@
 </file>
 
 <file path=ppt/slides/slide16.xml><?xml version="1.0" encoding="utf-8"?>
-<p:sld xmlns:a="http://schemas.openxmlformats.org/drawingml/2006/main" xmlns:p="http://schemas.openxmlformats.org/presentationml/2006/main" xmlns:r="http://schemas.openxmlformats.org/officeDocument/2006/relationships">
+<p:sld xmlns:a="http://schemas.openxmlformats.org/drawingml/2006/main" xmlns:r="http://schemas.openxmlformats.org/officeDocument/2006/relationships" xmlns:p="http://schemas.openxmlformats.org/presentationml/2006/main">
   <p:cSld>
     <p:bg>
       <p:bgPr>
@@ -8612,7 +8722,14 @@
         <p:cNvGrpSpPr/>
         <p:nvPr/>
       </p:nvGrpSpPr>
-      <p:grpSpPr/>
+      <p:grpSpPr>
+        <a:xfrm>
+          <a:off x="0" y="0"/>
+          <a:ext cx="0" cy="0"/>
+          <a:chOff x="0" y="0"/>
+          <a:chExt cx="0" cy="0"/>
+        </a:xfrm>
+      </p:grpSpPr>
       <p:sp>
         <p:nvSpPr>
           <p:cNvPr id="2" name="Rectangle 1"/>
@@ -8653,6 +8770,7 @@
           <a:lstStyle/>
           <a:p>
             <a:pPr algn="ctr"/>
+            <a:endParaRPr/>
           </a:p>
         </p:txBody>
       </p:sp>
@@ -8696,6 +8814,7 @@
           <a:lstStyle/>
           <a:p>
             <a:pPr algn="ctr"/>
+            <a:endParaRPr/>
           </a:p>
         </p:txBody>
       </p:sp>
@@ -8773,6 +8892,7 @@
           <a:lstStyle/>
           <a:p>
             <a:pPr algn="ctr"/>
+            <a:endParaRPr/>
           </a:p>
         </p:txBody>
       </p:sp>
@@ -8816,6 +8936,7 @@
           <a:lstStyle/>
           <a:p>
             <a:pPr algn="ctr"/>
+            <a:endParaRPr/>
           </a:p>
         </p:txBody>
       </p:sp>
@@ -8893,6 +9014,7 @@
           <a:lstStyle/>
           <a:p>
             <a:pPr algn="ctr"/>
+            <a:endParaRPr/>
           </a:p>
         </p:txBody>
       </p:sp>
@@ -8970,6 +9092,7 @@
           <a:lstStyle/>
           <a:p>
             <a:pPr algn="ctr"/>
+            <a:endParaRPr/>
           </a:p>
         </p:txBody>
       </p:sp>
@@ -9047,6 +9170,7 @@
           <a:lstStyle/>
           <a:p>
             <a:pPr algn="ctr"/>
+            <a:endParaRPr/>
           </a:p>
         </p:txBody>
       </p:sp>
@@ -9124,6 +9248,7 @@
           <a:lstStyle/>
           <a:p>
             <a:pPr algn="ctr"/>
+            <a:endParaRPr/>
           </a:p>
         </p:txBody>
       </p:sp>
@@ -9201,6 +9326,7 @@
           <a:lstStyle/>
           <a:p>
             <a:pPr algn="ctr"/>
+            <a:endParaRPr/>
           </a:p>
         </p:txBody>
       </p:sp>
@@ -9281,7 +9407,7 @@
 </file>
 
 <file path=ppt/slides/slide2.xml><?xml version="1.0" encoding="utf-8"?>
-<p:sld xmlns:a="http://schemas.openxmlformats.org/drawingml/2006/main" xmlns:p="http://schemas.openxmlformats.org/presentationml/2006/main" xmlns:r="http://schemas.openxmlformats.org/officeDocument/2006/relationships">
+<p:sld xmlns:a="http://schemas.openxmlformats.org/drawingml/2006/main" xmlns:r="http://schemas.openxmlformats.org/officeDocument/2006/relationships" xmlns:p="http://schemas.openxmlformats.org/presentationml/2006/main">
   <p:cSld>
     <p:bg>
       <p:bgPr>
@@ -9297,7 +9423,14 @@
         <p:cNvGrpSpPr/>
         <p:nvPr/>
       </p:nvGrpSpPr>
-      <p:grpSpPr/>
+      <p:grpSpPr>
+        <a:xfrm>
+          <a:off x="0" y="0"/>
+          <a:ext cx="0" cy="0"/>
+          <a:chOff x="0" y="0"/>
+          <a:chExt cx="0" cy="0"/>
+        </a:xfrm>
+      </p:grpSpPr>
       <p:sp>
         <p:nvSpPr>
           <p:cNvPr id="2" name="Rectangle 1"/>
@@ -9338,6 +9471,7 @@
           <a:lstStyle/>
           <a:p>
             <a:pPr algn="ctr"/>
+            <a:endParaRPr/>
           </a:p>
         </p:txBody>
       </p:sp>
@@ -9365,12 +9499,12 @@
           <a:p>
             <a:pPr algn="ctr"/>
             <a:r>
-              <a:rPr sz="3200" b="1" i="0">
+              <a:rPr sz="3200" b="1">
                 <a:solidFill>
                   <a:srgbClr val="FFFFFF"/>
                 </a:solidFill>
               </a:rPr>
-              <a:t>Team Members</a:t>
+              <a:t>Group Members</a:t>
             </a:r>
           </a:p>
         </p:txBody>
@@ -9415,6 +9549,7 @@
           <a:lstStyle/>
           <a:p>
             <a:pPr algn="ctr"/>
+            <a:endParaRPr/>
           </a:p>
         </p:txBody>
       </p:sp>
@@ -9458,6 +9593,7 @@
           <a:lstStyle/>
           <a:p>
             <a:pPr algn="ctr"/>
+            <a:endParaRPr/>
           </a:p>
         </p:txBody>
       </p:sp>
@@ -9501,6 +9637,7 @@
           <a:lstStyle/>
           <a:p>
             <a:pPr algn="ctr"/>
+            <a:endParaRPr/>
           </a:p>
         </p:txBody>
       </p:sp>
@@ -9528,7 +9665,7 @@
           <a:p>
             <a:pPr algn="ctr"/>
             <a:r>
-              <a:rPr sz="1800" b="1" i="0">
+              <a:rPr sz="1800" b="1">
                 <a:solidFill>
                   <a:srgbClr val="FFFFFF"/>
                 </a:solidFill>
@@ -9562,12 +9699,12 @@
           <a:p>
             <a:pPr algn="l"/>
             <a:r>
-              <a:rPr sz="1700" b="1" i="0">
+              <a:rPr sz="1700" b="1">
                 <a:solidFill>
                   <a:srgbClr val="1A1A2E"/>
                 </a:solidFill>
               </a:rPr>
-              <a:t>TIGIST MARKOS</a:t>
+              <a:t>AYELE MOGES</a:t>
             </a:r>
           </a:p>
         </p:txBody>
@@ -9596,12 +9733,12 @@
           <a:p>
             <a:pPr algn="r"/>
             <a:r>
-              <a:rPr sz="1500" b="0" i="0">
+              <a:rPr sz="1500" b="0">
                 <a:solidFill>
                   <a:srgbClr val="1A376C"/>
                 </a:solidFill>
               </a:rPr>
-              <a:t>GUR/00475/16</a:t>
+              <a:t>GUR/01091/16</a:t>
             </a:r>
           </a:p>
         </p:txBody>
@@ -9646,6 +9783,7 @@
           <a:lstStyle/>
           <a:p>
             <a:pPr algn="ctr"/>
+            <a:endParaRPr/>
           </a:p>
         </p:txBody>
       </p:sp>
@@ -9689,6 +9827,7 @@
           <a:lstStyle/>
           <a:p>
             <a:pPr algn="ctr"/>
+            <a:endParaRPr/>
           </a:p>
         </p:txBody>
       </p:sp>
@@ -9716,7 +9855,7 @@
           <a:p>
             <a:pPr algn="ctr"/>
             <a:r>
-              <a:rPr sz="1800" b="1" i="0">
+              <a:rPr sz="1800" b="1">
                 <a:solidFill>
                   <a:srgbClr val="FFFFFF"/>
                 </a:solidFill>
@@ -9750,12 +9889,12 @@
           <a:p>
             <a:pPr algn="l"/>
             <a:r>
-              <a:rPr sz="1700" b="1" i="0">
+              <a:rPr sz="1700" b="1">
                 <a:solidFill>
                   <a:srgbClr val="1A1A2E"/>
                 </a:solidFill>
               </a:rPr>
-              <a:t>YOHANNES AYELE</a:t>
+              <a:t>BIRIHANEKULU TAFERE</a:t>
             </a:r>
           </a:p>
         </p:txBody>
@@ -9784,12 +9923,12 @@
           <a:p>
             <a:pPr algn="r"/>
             <a:r>
-              <a:rPr sz="1500" b="0" i="0">
+              <a:rPr sz="1500" b="0">
                 <a:solidFill>
                   <a:srgbClr val="1A376C"/>
                 </a:solidFill>
               </a:rPr>
-              <a:t>GUR/00705/16</a:t>
+              <a:t>GUR/01115/16</a:t>
             </a:r>
           </a:p>
         </p:txBody>
@@ -9834,6 +9973,7 @@
           <a:lstStyle/>
           <a:p>
             <a:pPr algn="ctr"/>
+            <a:endParaRPr/>
           </a:p>
         </p:txBody>
       </p:sp>
@@ -9877,6 +10017,7 @@
           <a:lstStyle/>
           <a:p>
             <a:pPr algn="ctr"/>
+            <a:endParaRPr/>
           </a:p>
         </p:txBody>
       </p:sp>
@@ -9904,7 +10045,7 @@
           <a:p>
             <a:pPr algn="ctr"/>
             <a:r>
-              <a:rPr sz="1800" b="1" i="0">
+              <a:rPr sz="1800" b="1">
                 <a:solidFill>
                   <a:srgbClr val="FFFFFF"/>
                 </a:solidFill>
@@ -9938,12 +10079,12 @@
           <a:p>
             <a:pPr algn="l"/>
             <a:r>
-              <a:rPr sz="1700" b="1" i="0">
+              <a:rPr sz="1700" b="1">
                 <a:solidFill>
                   <a:srgbClr val="1A1A2E"/>
                 </a:solidFill>
               </a:rPr>
-              <a:t>YOHANNES HAILU</a:t>
+              <a:t>AMARE MINAYEHU</a:t>
             </a:r>
           </a:p>
         </p:txBody>
@@ -9972,12 +10113,12 @@
           <a:p>
             <a:pPr algn="r"/>
             <a:r>
-              <a:rPr sz="1500" b="0" i="0">
+              <a:rPr sz="1500" b="0">
                 <a:solidFill>
                   <a:srgbClr val="1A376C"/>
                 </a:solidFill>
               </a:rPr>
-              <a:t>GUR/00706/16</a:t>
+              <a:t>GUR/22885/16</a:t>
             </a:r>
           </a:p>
         </p:txBody>
@@ -10022,6 +10163,7 @@
           <a:lstStyle/>
           <a:p>
             <a:pPr algn="ctr"/>
+            <a:endParaRPr/>
           </a:p>
         </p:txBody>
       </p:sp>
@@ -10065,6 +10207,7 @@
           <a:lstStyle/>
           <a:p>
             <a:pPr algn="ctr"/>
+            <a:endParaRPr/>
           </a:p>
         </p:txBody>
       </p:sp>
@@ -10092,7 +10235,7 @@
           <a:p>
             <a:pPr algn="ctr"/>
             <a:r>
-              <a:rPr sz="1800" b="1" i="0">
+              <a:rPr sz="1800" b="1">
                 <a:solidFill>
                   <a:srgbClr val="FFFFFF"/>
                 </a:solidFill>
@@ -10126,12 +10269,12 @@
           <a:p>
             <a:pPr algn="l"/>
             <a:r>
-              <a:rPr sz="1700" b="1" i="0">
+              <a:rPr sz="1700" b="1">
                 <a:solidFill>
                   <a:srgbClr val="1A1A2E"/>
                 </a:solidFill>
               </a:rPr>
-              <a:t>YONAS GETACHEW</a:t>
+              <a:t>BEZAWIT DESALEGN</a:t>
             </a:r>
           </a:p>
         </p:txBody>
@@ -10160,12 +10303,12 @@
           <a:p>
             <a:pPr algn="r"/>
             <a:r>
-              <a:rPr sz="1500" b="0" i="0">
+              <a:rPr sz="1500" b="0">
                 <a:solidFill>
                   <a:srgbClr val="1A376C"/>
                 </a:solidFill>
               </a:rPr>
-              <a:t>GUR/00710/16</a:t>
+              <a:t>GUR/01199/16</a:t>
             </a:r>
           </a:p>
         </p:txBody>
@@ -10210,6 +10353,7 @@
           <a:lstStyle/>
           <a:p>
             <a:pPr algn="ctr"/>
+            <a:endParaRPr/>
           </a:p>
         </p:txBody>
       </p:sp>
@@ -10253,6 +10397,7 @@
           <a:lstStyle/>
           <a:p>
             <a:pPr algn="ctr"/>
+            <a:endParaRPr/>
           </a:p>
         </p:txBody>
       </p:sp>
@@ -10280,7 +10425,7 @@
           <a:p>
             <a:pPr algn="ctr"/>
             <a:r>
-              <a:rPr sz="1800" b="1" i="0">
+              <a:rPr sz="1800" b="1">
                 <a:solidFill>
                   <a:srgbClr val="FFFFFF"/>
                 </a:solidFill>
@@ -10314,12 +10459,12 @@
           <a:p>
             <a:pPr algn="l"/>
             <a:r>
-              <a:rPr sz="1700" b="1" i="0">
+              <a:rPr sz="1700" b="1">
                 <a:solidFill>
                   <a:srgbClr val="1A1A2E"/>
                 </a:solidFill>
               </a:rPr>
-              <a:t>YORDANOS TESFAYE</a:t>
+              <a:t>TIGIST MARKOS</a:t>
             </a:r>
           </a:p>
         </p:txBody>
@@ -10348,12 +10493,12 @@
           <a:p>
             <a:pPr algn="r"/>
             <a:r>
-              <a:rPr sz="1500" b="0" i="0">
+              <a:rPr sz="1500" b="0">
                 <a:solidFill>
                   <a:srgbClr val="1A376C"/>
                 </a:solidFill>
               </a:rPr>
-              <a:t>GUR/00714/16</a:t>
+              <a:t>GUR/00475/16</a:t>
             </a:r>
           </a:p>
         </p:txBody>
@@ -10367,7 +10512,7 @@
 </file>
 
 <file path=ppt/slides/slide3.xml><?xml version="1.0" encoding="utf-8"?>
-<p:sld xmlns:a="http://schemas.openxmlformats.org/drawingml/2006/main" xmlns:p="http://schemas.openxmlformats.org/presentationml/2006/main" xmlns:r="http://schemas.openxmlformats.org/officeDocument/2006/relationships">
+<p:sld xmlns:a="http://schemas.openxmlformats.org/drawingml/2006/main" xmlns:r="http://schemas.openxmlformats.org/officeDocument/2006/relationships" xmlns:p="http://schemas.openxmlformats.org/presentationml/2006/main">
   <p:cSld>
     <p:bg>
       <p:bgPr>
@@ -10383,7 +10528,14 @@
         <p:cNvGrpSpPr/>
         <p:nvPr/>
       </p:nvGrpSpPr>
-      <p:grpSpPr/>
+      <p:grpSpPr>
+        <a:xfrm>
+          <a:off x="0" y="0"/>
+          <a:ext cx="0" cy="0"/>
+          <a:chOff x="0" y="0"/>
+          <a:chExt cx="0" cy="0"/>
+        </a:xfrm>
+      </p:grpSpPr>
       <p:sp>
         <p:nvSpPr>
           <p:cNvPr id="2" name="Rectangle 1"/>
@@ -10424,6 +10576,7 @@
           <a:lstStyle/>
           <a:p>
             <a:pPr algn="ctr"/>
+            <a:endParaRPr/>
           </a:p>
         </p:txBody>
       </p:sp>
@@ -10501,6 +10654,7 @@
           <a:lstStyle/>
           <a:p>
             <a:pPr algn="ctr"/>
+            <a:endParaRPr/>
           </a:p>
         </p:txBody>
       </p:sp>
@@ -10544,6 +10698,7 @@
           <a:lstStyle/>
           <a:p>
             <a:pPr algn="ctr"/>
+            <a:endParaRPr/>
           </a:p>
         </p:txBody>
       </p:sp>
@@ -10621,6 +10776,7 @@
           <a:lstStyle/>
           <a:p>
             <a:pPr algn="ctr"/>
+            <a:endParaRPr/>
           </a:p>
         </p:txBody>
       </p:sp>
@@ -10698,6 +10854,7 @@
           <a:lstStyle/>
           <a:p>
             <a:pPr algn="ctr"/>
+            <a:endParaRPr/>
           </a:p>
         </p:txBody>
       </p:sp>
@@ -10775,6 +10932,7 @@
           <a:lstStyle/>
           <a:p>
             <a:pPr algn="ctr"/>
+            <a:endParaRPr/>
           </a:p>
         </p:txBody>
       </p:sp>
@@ -10852,6 +11010,7 @@
           <a:lstStyle/>
           <a:p>
             <a:pPr algn="ctr"/>
+            <a:endParaRPr/>
           </a:p>
         </p:txBody>
       </p:sp>
@@ -10929,6 +11088,7 @@
           <a:lstStyle/>
           <a:p>
             <a:pPr algn="ctr"/>
+            <a:endParaRPr/>
           </a:p>
         </p:txBody>
       </p:sp>
@@ -11006,6 +11166,7 @@
           <a:lstStyle/>
           <a:p>
             <a:pPr algn="ctr"/>
+            <a:endParaRPr/>
           </a:p>
         </p:txBody>
       </p:sp>
@@ -11083,6 +11244,7 @@
           <a:lstStyle/>
           <a:p>
             <a:pPr algn="ctr"/>
+            <a:endParaRPr/>
           </a:p>
         </p:txBody>
       </p:sp>
@@ -11160,6 +11322,7 @@
           <a:lstStyle/>
           <a:p>
             <a:pPr algn="ctr"/>
+            <a:endParaRPr/>
           </a:p>
         </p:txBody>
       </p:sp>
@@ -11237,6 +11400,7 @@
           <a:lstStyle/>
           <a:p>
             <a:pPr algn="ctr"/>
+            <a:endParaRPr/>
           </a:p>
         </p:txBody>
       </p:sp>
@@ -11314,6 +11478,7 @@
           <a:lstStyle/>
           <a:p>
             <a:pPr algn="ctr"/>
+            <a:endParaRPr/>
           </a:p>
         </p:txBody>
       </p:sp>
@@ -11391,6 +11556,7 @@
           <a:lstStyle/>
           <a:p>
             <a:pPr algn="ctr"/>
+            <a:endParaRPr/>
           </a:p>
         </p:txBody>
       </p:sp>
@@ -11468,6 +11634,7 @@
           <a:lstStyle/>
           <a:p>
             <a:pPr algn="ctr"/>
+            <a:endParaRPr/>
           </a:p>
         </p:txBody>
       </p:sp>
@@ -11514,7 +11681,7 @@
 </file>
 
 <file path=ppt/slides/slide4.xml><?xml version="1.0" encoding="utf-8"?>
-<p:sld xmlns:a="http://schemas.openxmlformats.org/drawingml/2006/main" xmlns:p="http://schemas.openxmlformats.org/presentationml/2006/main" xmlns:r="http://schemas.openxmlformats.org/officeDocument/2006/relationships">
+<p:sld xmlns:a="http://schemas.openxmlformats.org/drawingml/2006/main" xmlns:r="http://schemas.openxmlformats.org/officeDocument/2006/relationships" xmlns:p="http://schemas.openxmlformats.org/presentationml/2006/main">
   <p:cSld>
     <p:bg>
       <p:bgPr>
@@ -11530,7 +11697,14 @@
         <p:cNvGrpSpPr/>
         <p:nvPr/>
       </p:nvGrpSpPr>
-      <p:grpSpPr/>
+      <p:grpSpPr>
+        <a:xfrm>
+          <a:off x="0" y="0"/>
+          <a:ext cx="0" cy="0"/>
+          <a:chOff x="0" y="0"/>
+          <a:chExt cx="0" cy="0"/>
+        </a:xfrm>
+      </p:grpSpPr>
       <p:sp>
         <p:nvSpPr>
           <p:cNvPr id="2" name="Rectangle 1"/>
@@ -11571,6 +11745,7 @@
           <a:lstStyle/>
           <a:p>
             <a:pPr algn="ctr"/>
+            <a:endParaRPr/>
           </a:p>
         </p:txBody>
       </p:sp>
@@ -11648,6 +11823,7 @@
           <a:lstStyle/>
           <a:p>
             <a:pPr algn="ctr"/>
+            <a:endParaRPr/>
           </a:p>
         </p:txBody>
       </p:sp>
@@ -11691,6 +11867,7 @@
           <a:lstStyle/>
           <a:p>
             <a:pPr algn="ctr"/>
+            <a:endParaRPr/>
           </a:p>
         </p:txBody>
       </p:sp>
@@ -11768,6 +11945,7 @@
           <a:lstStyle/>
           <a:p>
             <a:pPr algn="ctr"/>
+            <a:endParaRPr/>
           </a:p>
         </p:txBody>
       </p:sp>
@@ -11845,6 +12023,7 @@
           <a:lstStyle/>
           <a:p>
             <a:pPr algn="ctr"/>
+            <a:endParaRPr/>
           </a:p>
         </p:txBody>
       </p:sp>
@@ -11922,6 +12101,7 @@
           <a:lstStyle/>
           <a:p>
             <a:pPr algn="ctr"/>
+            <a:endParaRPr/>
           </a:p>
         </p:txBody>
       </p:sp>
@@ -11999,6 +12179,7 @@
           <a:lstStyle/>
           <a:p>
             <a:pPr algn="ctr"/>
+            <a:endParaRPr/>
           </a:p>
         </p:txBody>
       </p:sp>
@@ -12076,6 +12257,7 @@
           <a:lstStyle/>
           <a:p>
             <a:pPr algn="ctr"/>
+            <a:endParaRPr/>
           </a:p>
         </p:txBody>
       </p:sp>
@@ -12153,6 +12335,7 @@
           <a:lstStyle/>
           <a:p>
             <a:pPr algn="ctr"/>
+            <a:endParaRPr/>
           </a:p>
         </p:txBody>
       </p:sp>
@@ -12230,6 +12413,7 @@
           <a:lstStyle/>
           <a:p>
             <a:pPr algn="ctr"/>
+            <a:endParaRPr/>
           </a:p>
         </p:txBody>
       </p:sp>
@@ -12276,7 +12460,7 @@
 </file>
 
 <file path=ppt/slides/slide5.xml><?xml version="1.0" encoding="utf-8"?>
-<p:sld xmlns:a="http://schemas.openxmlformats.org/drawingml/2006/main" xmlns:p="http://schemas.openxmlformats.org/presentationml/2006/main" xmlns:r="http://schemas.openxmlformats.org/officeDocument/2006/relationships">
+<p:sld xmlns:a="http://schemas.openxmlformats.org/drawingml/2006/main" xmlns:r="http://schemas.openxmlformats.org/officeDocument/2006/relationships" xmlns:p="http://schemas.openxmlformats.org/presentationml/2006/main">
   <p:cSld>
     <p:bg>
       <p:bgPr>
@@ -12292,7 +12476,14 @@
         <p:cNvGrpSpPr/>
         <p:nvPr/>
       </p:nvGrpSpPr>
-      <p:grpSpPr/>
+      <p:grpSpPr>
+        <a:xfrm>
+          <a:off x="0" y="0"/>
+          <a:ext cx="0" cy="0"/>
+          <a:chOff x="0" y="0"/>
+          <a:chExt cx="0" cy="0"/>
+        </a:xfrm>
+      </p:grpSpPr>
       <p:sp>
         <p:nvSpPr>
           <p:cNvPr id="2" name="Rectangle 1"/>
@@ -12302,7 +12493,7 @@
         <p:spPr>
           <a:xfrm>
             <a:off x="0" y="0"/>
-            <a:ext cx="12188952" cy="1280160"/>
+            <a:ext cx="12188952" cy="960120"/>
           </a:xfrm>
           <a:prstGeom prst="rect">
             <a:avLst/>
@@ -12333,6 +12524,7 @@
           <a:lstStyle/>
           <a:p>
             <a:pPr algn="ctr"/>
+            <a:endParaRPr/>
           </a:p>
         </p:txBody>
       </p:sp>
@@ -12410,6 +12602,7 @@
           <a:lstStyle/>
           <a:p>
             <a:pPr algn="ctr"/>
+            <a:endParaRPr/>
           </a:p>
         </p:txBody>
       </p:sp>
@@ -12487,6 +12680,7 @@
           <a:lstStyle/>
           <a:p>
             <a:pPr algn="ctr"/>
+            <a:endParaRPr/>
           </a:p>
         </p:txBody>
       </p:sp>
@@ -12514,7 +12708,7 @@
           <a:p>
             <a:pPr algn="l"/>
             <a:r>
-              <a:rPr sz="1500" b="0" i="0">
+              <a:rPr sz="1500" b="0" i="0" dirty="0">
                 <a:solidFill>
                   <a:srgbClr val="1A1A2E"/>
                 </a:solidFill>
@@ -12564,6 +12758,7 @@
           <a:lstStyle/>
           <a:p>
             <a:pPr algn="ctr"/>
+            <a:endParaRPr/>
           </a:p>
         </p:txBody>
       </p:sp>
@@ -12576,7 +12771,7 @@
         <p:spPr>
           <a:xfrm>
             <a:off x="548640" y="2359152"/>
-            <a:ext cx="11247120" cy="411480"/>
+            <a:ext cx="11247120" cy="323165"/>
           </a:xfrm>
           <a:prstGeom prst="rect">
             <a:avLst/>
@@ -12591,7 +12786,7 @@
           <a:p>
             <a:pPr algn="l"/>
             <a:r>
-              <a:rPr sz="1500" b="0" i="0">
+              <a:rPr sz="1500" b="1" i="0">
                 <a:solidFill>
                   <a:srgbClr val="1A1A2E"/>
                 </a:solidFill>
@@ -12641,6 +12836,7 @@
           <a:lstStyle/>
           <a:p>
             <a:pPr algn="ctr"/>
+            <a:endParaRPr/>
           </a:p>
         </p:txBody>
       </p:sp>
@@ -12653,7 +12849,7 @@
         <p:spPr>
           <a:xfrm>
             <a:off x="548640" y="2798064"/>
-            <a:ext cx="11247120" cy="411480"/>
+            <a:ext cx="11247120" cy="323165"/>
           </a:xfrm>
           <a:prstGeom prst="rect">
             <a:avLst/>
@@ -12668,12 +12864,28 @@
           <a:p>
             <a:pPr algn="l"/>
             <a:r>
-              <a:rPr sz="1500" b="0" i="0">
+              <a:rPr sz="1500" b="0" i="0" dirty="0">
                 <a:solidFill>
                   <a:srgbClr val="1A1A2E"/>
                 </a:solidFill>
               </a:rPr>
-              <a:t>Low health literacy — delayed care-seeking for preventable conditions</a:t>
+              <a:t>Low health </a:t>
+            </a:r>
+            <a:r>
+              <a:rPr sz="1500" b="1" i="0" dirty="0">
+                <a:solidFill>
+                  <a:srgbClr val="1A1A2E"/>
+                </a:solidFill>
+              </a:rPr>
+              <a:t>literacy</a:t>
+            </a:r>
+            <a:r>
+              <a:rPr sz="1500" b="0" i="0" dirty="0">
+                <a:solidFill>
+                  <a:srgbClr val="1A1A2E"/>
+                </a:solidFill>
+              </a:rPr>
+              <a:t> — delayed care-seeking for preventable conditions</a:t>
             </a:r>
           </a:p>
         </p:txBody>
@@ -12718,6 +12930,7 @@
           <a:lstStyle/>
           <a:p>
             <a:pPr algn="ctr"/>
+            <a:endParaRPr/>
           </a:p>
         </p:txBody>
       </p:sp>
@@ -12745,7 +12958,7 @@
           <a:p>
             <a:pPr algn="l"/>
             <a:r>
-              <a:rPr sz="1500" b="0" i="0">
+              <a:rPr sz="1500" b="0" i="0" dirty="0">
                 <a:solidFill>
                   <a:srgbClr val="1A1A2E"/>
                 </a:solidFill>
@@ -12795,6 +13008,7 @@
           <a:lstStyle/>
           <a:p>
             <a:pPr algn="ctr"/>
+            <a:endParaRPr/>
           </a:p>
         </p:txBody>
       </p:sp>
@@ -12872,6 +13086,7 @@
           <a:lstStyle/>
           <a:p>
             <a:pPr algn="ctr"/>
+            <a:endParaRPr/>
           </a:p>
         </p:txBody>
       </p:sp>
@@ -12983,6 +13198,7 @@
           <a:lstStyle/>
           <a:p>
             <a:pPr algn="ctr"/>
+            <a:endParaRPr/>
           </a:p>
         </p:txBody>
       </p:sp>
@@ -13029,7 +13245,7 @@
 </file>
 
 <file path=ppt/slides/slide6.xml><?xml version="1.0" encoding="utf-8"?>
-<p:sld xmlns:a="http://schemas.openxmlformats.org/drawingml/2006/main" xmlns:p="http://schemas.openxmlformats.org/presentationml/2006/main" xmlns:r="http://schemas.openxmlformats.org/officeDocument/2006/relationships">
+<p:sld xmlns:a="http://schemas.openxmlformats.org/drawingml/2006/main" xmlns:r="http://schemas.openxmlformats.org/officeDocument/2006/relationships" xmlns:p="http://schemas.openxmlformats.org/presentationml/2006/main">
   <p:cSld>
     <p:bg>
       <p:bgPr>
@@ -13045,7 +13261,14 @@
         <p:cNvGrpSpPr/>
         <p:nvPr/>
       </p:nvGrpSpPr>
-      <p:grpSpPr/>
+      <p:grpSpPr>
+        <a:xfrm>
+          <a:off x="0" y="0"/>
+          <a:ext cx="0" cy="0"/>
+          <a:chOff x="0" y="0"/>
+          <a:chExt cx="0" cy="0"/>
+        </a:xfrm>
+      </p:grpSpPr>
       <p:sp>
         <p:nvSpPr>
           <p:cNvPr id="2" name="Rectangle 1"/>
@@ -13086,6 +13309,7 @@
           <a:lstStyle/>
           <a:p>
             <a:pPr algn="ctr"/>
+            <a:endParaRPr/>
           </a:p>
         </p:txBody>
       </p:sp>
@@ -13163,6 +13387,7 @@
           <a:lstStyle/>
           <a:p>
             <a:pPr algn="ctr"/>
+            <a:endParaRPr/>
           </a:p>
         </p:txBody>
       </p:sp>
@@ -13240,6 +13465,7 @@
           <a:lstStyle/>
           <a:p>
             <a:pPr algn="ctr"/>
+            <a:endParaRPr/>
           </a:p>
         </p:txBody>
       </p:sp>
@@ -13351,6 +13577,7 @@
           <a:lstStyle/>
           <a:p>
             <a:pPr algn="ctr"/>
+            <a:endParaRPr/>
           </a:p>
         </p:txBody>
       </p:sp>
@@ -13428,6 +13655,7 @@
           <a:lstStyle/>
           <a:p>
             <a:pPr algn="ctr"/>
+            <a:endParaRPr/>
           </a:p>
         </p:txBody>
       </p:sp>
@@ -13505,6 +13733,7 @@
           <a:lstStyle/>
           <a:p>
             <a:pPr algn="ctr"/>
+            <a:endParaRPr/>
           </a:p>
         </p:txBody>
       </p:sp>
@@ -13582,6 +13811,7 @@
           <a:lstStyle/>
           <a:p>
             <a:pPr algn="ctr"/>
+            <a:endParaRPr/>
           </a:p>
         </p:txBody>
       </p:sp>
@@ -13659,6 +13889,7 @@
           <a:lstStyle/>
           <a:p>
             <a:pPr algn="ctr"/>
+            <a:endParaRPr/>
           </a:p>
         </p:txBody>
       </p:sp>
@@ -13736,6 +13967,7 @@
           <a:lstStyle/>
           <a:p>
             <a:pPr algn="ctr"/>
+            <a:endParaRPr/>
           </a:p>
         </p:txBody>
       </p:sp>
@@ -13782,7 +14014,7 @@
 </file>
 
 <file path=ppt/slides/slide7.xml><?xml version="1.0" encoding="utf-8"?>
-<p:sld xmlns:a="http://schemas.openxmlformats.org/drawingml/2006/main" xmlns:p="http://schemas.openxmlformats.org/presentationml/2006/main" xmlns:r="http://schemas.openxmlformats.org/officeDocument/2006/relationships">
+<p:sld xmlns:a="http://schemas.openxmlformats.org/drawingml/2006/main" xmlns:r="http://schemas.openxmlformats.org/officeDocument/2006/relationships" xmlns:p="http://schemas.openxmlformats.org/presentationml/2006/main">
   <p:cSld>
     <p:bg>
       <p:bgPr>
@@ -13798,7 +14030,14 @@
         <p:cNvGrpSpPr/>
         <p:nvPr/>
       </p:nvGrpSpPr>
-      <p:grpSpPr/>
+      <p:grpSpPr>
+        <a:xfrm>
+          <a:off x="0" y="0"/>
+          <a:ext cx="0" cy="0"/>
+          <a:chOff x="0" y="0"/>
+          <a:chExt cx="0" cy="0"/>
+        </a:xfrm>
+      </p:grpSpPr>
       <p:sp>
         <p:nvSpPr>
           <p:cNvPr id="2" name="Rectangle 1"/>
@@ -13839,6 +14078,7 @@
           <a:lstStyle/>
           <a:p>
             <a:pPr algn="ctr"/>
+            <a:endParaRPr/>
           </a:p>
         </p:txBody>
       </p:sp>
@@ -13916,6 +14156,7 @@
           <a:lstStyle/>
           <a:p>
             <a:pPr algn="ctr"/>
+            <a:endParaRPr/>
           </a:p>
         </p:txBody>
       </p:sp>
@@ -13993,6 +14234,7 @@
           <a:lstStyle/>
           <a:p>
             <a:pPr algn="ctr"/>
+            <a:endParaRPr/>
           </a:p>
         </p:txBody>
       </p:sp>
@@ -14070,6 +14312,7 @@
           <a:lstStyle/>
           <a:p>
             <a:pPr algn="ctr"/>
+            <a:endParaRPr/>
           </a:p>
         </p:txBody>
       </p:sp>
@@ -14147,6 +14390,7 @@
           <a:lstStyle/>
           <a:p>
             <a:pPr algn="ctr"/>
+            <a:endParaRPr/>
           </a:p>
         </p:txBody>
       </p:sp>
@@ -14258,6 +14502,7 @@
           <a:lstStyle/>
           <a:p>
             <a:pPr algn="ctr"/>
+            <a:endParaRPr/>
           </a:p>
         </p:txBody>
       </p:sp>
@@ -14335,6 +14580,7 @@
           <a:lstStyle/>
           <a:p>
             <a:pPr algn="ctr"/>
+            <a:endParaRPr/>
           </a:p>
         </p:txBody>
       </p:sp>
@@ -14446,6 +14692,7 @@
           <a:lstStyle/>
           <a:p>
             <a:pPr algn="ctr"/>
+            <a:endParaRPr/>
           </a:p>
         </p:txBody>
       </p:sp>
@@ -14523,6 +14770,7 @@
           <a:lstStyle/>
           <a:p>
             <a:pPr algn="ctr"/>
+            <a:endParaRPr/>
           </a:p>
         </p:txBody>
       </p:sp>
@@ -14569,7 +14817,7 @@
 </file>
 
 <file path=ppt/slides/slide8.xml><?xml version="1.0" encoding="utf-8"?>
-<p:sld xmlns:a="http://schemas.openxmlformats.org/drawingml/2006/main" xmlns:p="http://schemas.openxmlformats.org/presentationml/2006/main" xmlns:r="http://schemas.openxmlformats.org/officeDocument/2006/relationships">
+<p:sld xmlns:a="http://schemas.openxmlformats.org/drawingml/2006/main" xmlns:r="http://schemas.openxmlformats.org/officeDocument/2006/relationships" xmlns:p="http://schemas.openxmlformats.org/presentationml/2006/main">
   <p:cSld>
     <p:bg>
       <p:bgPr>
@@ -14585,7 +14833,14 @@
         <p:cNvGrpSpPr/>
         <p:nvPr/>
       </p:nvGrpSpPr>
-      <p:grpSpPr/>
+      <p:grpSpPr>
+        <a:xfrm>
+          <a:off x="0" y="0"/>
+          <a:ext cx="0" cy="0"/>
+          <a:chOff x="0" y="0"/>
+          <a:chExt cx="0" cy="0"/>
+        </a:xfrm>
+      </p:grpSpPr>
       <p:sp>
         <p:nvSpPr>
           <p:cNvPr id="2" name="Rectangle 1"/>
@@ -14626,6 +14881,7 @@
           <a:lstStyle/>
           <a:p>
             <a:pPr algn="ctr"/>
+            <a:endParaRPr/>
           </a:p>
         </p:txBody>
       </p:sp>
@@ -14703,6 +14959,7 @@
           <a:lstStyle/>
           <a:p>
             <a:pPr algn="ctr"/>
+            <a:endParaRPr/>
           </a:p>
         </p:txBody>
       </p:sp>
@@ -14780,6 +15037,7 @@
           <a:lstStyle/>
           <a:p>
             <a:pPr algn="ctr"/>
+            <a:endParaRPr/>
           </a:p>
         </p:txBody>
       </p:sp>
@@ -14857,6 +15115,7 @@
           <a:lstStyle/>
           <a:p>
             <a:pPr algn="ctr"/>
+            <a:endParaRPr/>
           </a:p>
         </p:txBody>
       </p:sp>
@@ -14968,6 +15227,7 @@
           <a:lstStyle/>
           <a:p>
             <a:pPr algn="ctr"/>
+            <a:endParaRPr/>
           </a:p>
         </p:txBody>
       </p:sp>
@@ -15045,6 +15305,7 @@
           <a:lstStyle/>
           <a:p>
             <a:pPr algn="ctr"/>
+            <a:endParaRPr/>
           </a:p>
         </p:txBody>
       </p:sp>
@@ -15122,6 +15383,7 @@
           <a:lstStyle/>
           <a:p>
             <a:pPr algn="ctr"/>
+            <a:endParaRPr/>
           </a:p>
         </p:txBody>
       </p:sp>
@@ -15233,6 +15495,7 @@
           <a:lstStyle/>
           <a:p>
             <a:pPr algn="ctr"/>
+            <a:endParaRPr/>
           </a:p>
         </p:txBody>
       </p:sp>
@@ -15344,6 +15607,7 @@
           <a:lstStyle/>
           <a:p>
             <a:pPr algn="ctr"/>
+            <a:endParaRPr/>
           </a:p>
         </p:txBody>
       </p:sp>
@@ -15390,7 +15654,7 @@
 </file>
 
 <file path=ppt/slides/slide9.xml><?xml version="1.0" encoding="utf-8"?>
-<p:sld xmlns:a="http://schemas.openxmlformats.org/drawingml/2006/main" xmlns:p="http://schemas.openxmlformats.org/presentationml/2006/main" xmlns:r="http://schemas.openxmlformats.org/officeDocument/2006/relationships">
+<p:sld xmlns:a="http://schemas.openxmlformats.org/drawingml/2006/main" xmlns:r="http://schemas.openxmlformats.org/officeDocument/2006/relationships" xmlns:p="http://schemas.openxmlformats.org/presentationml/2006/main">
   <p:cSld>
     <p:bg>
       <p:bgPr>
@@ -15406,7 +15670,14 @@
         <p:cNvGrpSpPr/>
         <p:nvPr/>
       </p:nvGrpSpPr>
-      <p:grpSpPr/>
+      <p:grpSpPr>
+        <a:xfrm>
+          <a:off x="0" y="0"/>
+          <a:ext cx="0" cy="0"/>
+          <a:chOff x="0" y="0"/>
+          <a:chExt cx="0" cy="0"/>
+        </a:xfrm>
+      </p:grpSpPr>
       <p:sp>
         <p:nvSpPr>
           <p:cNvPr id="2" name="Rectangle 1"/>
@@ -15447,6 +15718,7 @@
           <a:lstStyle/>
           <a:p>
             <a:pPr algn="ctr"/>
+            <a:endParaRPr/>
           </a:p>
         </p:txBody>
       </p:sp>
@@ -15524,6 +15796,7 @@
           <a:lstStyle/>
           <a:p>
             <a:pPr algn="ctr"/>
+            <a:endParaRPr/>
           </a:p>
         </p:txBody>
       </p:sp>
@@ -15601,6 +15874,7 @@
           <a:lstStyle/>
           <a:p>
             <a:pPr algn="ctr"/>
+            <a:endParaRPr/>
           </a:p>
         </p:txBody>
       </p:sp>
@@ -15678,6 +15952,7 @@
           <a:lstStyle/>
           <a:p>
             <a:pPr algn="ctr"/>
+            <a:endParaRPr/>
           </a:p>
         </p:txBody>
       </p:sp>
@@ -15755,6 +16030,7 @@
           <a:lstStyle/>
           <a:p>
             <a:pPr algn="ctr"/>
+            <a:endParaRPr/>
           </a:p>
         </p:txBody>
       </p:sp>
@@ -15832,6 +16108,7 @@
           <a:lstStyle/>
           <a:p>
             <a:pPr algn="ctr"/>
+            <a:endParaRPr/>
           </a:p>
         </p:txBody>
       </p:sp>
@@ -15909,6 +16186,7 @@
           <a:lstStyle/>
           <a:p>
             <a:pPr algn="ctr"/>
+            <a:endParaRPr/>
           </a:p>
         </p:txBody>
       </p:sp>
@@ -15986,6 +16264,7 @@
           <a:lstStyle/>
           <a:p>
             <a:pPr algn="ctr"/>
+            <a:endParaRPr/>
           </a:p>
         </p:txBody>
       </p:sp>
@@ -16097,6 +16376,7 @@
           <a:lstStyle/>
           <a:p>
             <a:pPr algn="ctr"/>
+            <a:endParaRPr/>
           </a:p>
         </p:txBody>
       </p:sp>
@@ -16174,6 +16454,7 @@
           <a:lstStyle/>
           <a:p>
             <a:pPr algn="ctr"/>
+            <a:endParaRPr/>
           </a:p>
         </p:txBody>
       </p:sp>
@@ -16251,6 +16532,7 @@
           <a:lstStyle/>
           <a:p>
             <a:pPr algn="ctr"/>
+            <a:endParaRPr/>
           </a:p>
         </p:txBody>
       </p:sp>

</xml_diff>